<commit_message>
Lab 1: story intro, model from lakehouse ribbon, KPIs in the model, DAX files as manual option
</commit_message>
<xml_diff>
--- a/docs/images/source/workshop-diagrams.pptx
+++ b/docs/images/source/workshop-diagrams.pptx
@@ -6740,7 +6740,7 @@
                 </a:solidFill>
                 <a:latin typeface="Segoe UI"/>
               </a:rPr>
-              <a:t>OneLake catalog, no data copy</a:t>
+              <a:t>Lakehouse ribbon, no copy</a:t>
             </a:r>
           </a:p>
         </p:txBody>
@@ -7970,7 +7970,7 @@
                 </a:solidFill>
                 <a:latin typeface="Segoe UI"/>
               </a:rPr>
-              <a:t>Measures in DAX</a:t>
+              <a:t>3 business KPIs</a:t>
             </a:r>
           </a:p>
         </p:txBody>
@@ -8098,7 +8098,7 @@
                 </a:solidFill>
                 <a:latin typeface="Segoe UI"/>
               </a:rPr>
-              <a:t>Names, formats, folders</a:t>
+              <a:t>Names, hide, describe</a:t>
             </a:r>
           </a:p>
         </p:txBody>
@@ -8917,7 +8917,7 @@
         <p:spPr>
           <a:xfrm>
             <a:off x="4709160" y="5029200"/>
-            <a:ext cx="2349093" cy="292608"/>
+            <a:ext cx="1741932" cy="292608"/>
           </a:xfrm>
           <a:prstGeom prst="roundRect">
             <a:avLst>
@@ -9000,7 +9000,7 @@
         <p:spPr>
           <a:xfrm>
             <a:off x="5074920" y="5029200"/>
-            <a:ext cx="1937613" cy="292608"/>
+            <a:ext cx="1330452" cy="292608"/>
           </a:xfrm>
           <a:prstGeom prst="rect">
             <a:avLst/>
@@ -9028,7 +9028,7 @@
                 </a:solidFill>
                 <a:latin typeface="Segoe UI Semibold"/>
               </a:rPr>
-              <a:t>Step 4 · DAX query view</a:t>
+              <a:t>Step 4 · KPIs *</a:t>
             </a:r>
           </a:p>
         </p:txBody>
@@ -9042,7 +9042,7 @@
         <p:spPr>
           <a:xfrm>
             <a:off x="4709160" y="5413248"/>
-            <a:ext cx="2349093" cy="292608"/>
+            <a:ext cx="2045512" cy="292608"/>
           </a:xfrm>
           <a:prstGeom prst="roundRect">
             <a:avLst>
@@ -9125,7 +9125,7 @@
         <p:spPr>
           <a:xfrm>
             <a:off x="5074920" y="5413248"/>
-            <a:ext cx="1937613" cy="292608"/>
+            <a:ext cx="1634032" cy="292608"/>
           </a:xfrm>
           <a:prstGeom prst="rect">
             <a:avLst/>
@@ -9153,7 +9153,7 @@
                 </a:solidFill>
                 <a:latin typeface="Segoe UI Semibold"/>
               </a:rPr>
-              <a:t>Step 5 · Web modeling *</a:t>
+              <a:t>Step 5 · Clean-up *</a:t>
             </a:r>
           </a:p>
         </p:txBody>

</xml_diff>